<commit_message>
pptx updated with who is doing which layer
</commit_message>
<xml_diff>
--- a/Task_3/Task3Powerpoint.pptx
+++ b/Task_3/Task3Powerpoint.pptx
@@ -275,7 +275,7 @@
           <a:p>
             <a:fld id="{75AB4CA9-CCE6-4DE5-84AD-E1F7B6CB5CBB}" type="datetimeFigureOut">
               <a:rPr lang="de-DE" smtClean="0"/>
-              <a:t>09.07.2026</a:t>
+              <a:t>15.07.2026</a:t>
             </a:fld>
             <a:endParaRPr lang="de-DE"/>
           </a:p>
@@ -452,7 +452,7 @@
           <a:p>
             <a:fld id="{52D5829F-2F94-0B44-A96D-AE852A87AC61}" type="datetimeFigureOut">
               <a:rPr lang="de-DE" smtClean="0"/>
-              <a:t>09.07.2026</a:t>
+              <a:t>15.07.2026</a:t>
             </a:fld>
             <a:endParaRPr lang="de-DE"/>
           </a:p>
@@ -770,6 +770,18 @@
           <a:bodyPr/>
           <a:lstStyle/>
           <a:p>
+            <a:r>
+              <a:rPr lang="de-DE" sz="1200" b="0" kern="1200" dirty="0">
+                <a:solidFill>
+                  <a:schemeClr val="tx1"/>
+                </a:solidFill>
+                <a:effectLst/>
+                <a:latin typeface="+mn-lt"/>
+                <a:ea typeface="+mn-ea"/>
+                <a:cs typeface="+mn-cs"/>
+              </a:rPr>
+              <a:t>Victor</a:t>
+            </a:r>
             <a:endParaRPr lang="de-DE" dirty="0"/>
           </a:p>
           <a:p>
@@ -874,6 +886,20 @@
                 <a:ea typeface="+mn-ea"/>
                 <a:cs typeface="+mn-cs"/>
               </a:rPr>
+              <a:t>David</a:t>
+            </a:r>
+          </a:p>
+          <a:p>
+            <a:r>
+              <a:rPr lang="de-DE" sz="1200" b="0" kern="1200" dirty="0">
+                <a:solidFill>
+                  <a:schemeClr val="tx1"/>
+                </a:solidFill>
+                <a:effectLst/>
+                <a:latin typeface="+mn-lt"/>
+                <a:ea typeface="+mn-ea"/>
+                <a:cs typeface="+mn-cs"/>
+              </a:rPr>
               <a:t>Die Hyperparameter werden nicht auf dem Testsatz ausgewählt. Für jede Kombination trainieren wir auf dem Trainingssatz und bewerten auf dem Entwicklungssatz. Das beste Modell wird anhand der Entwicklungs-Metriken ausgewählt. Danach wird das finale Modell mit Training plus Entwicklung neu trainiert und erst dann auf dem Testsatz bewertet.</a:t>
             </a:r>
           </a:p>
@@ -993,6 +1019,37 @@
                 <a:ea typeface="+mn-ea"/>
                 <a:cs typeface="+mn-cs"/>
               </a:rPr>
+              <a:t>David</a:t>
+            </a:r>
+          </a:p>
+          <a:p>
+            <a:pPr marL="0" marR="0" lvl="0" indent="0" algn="l" defTabSz="914400" rtl="0" eaLnBrk="1" fontAlgn="auto" latinLnBrk="0" hangingPunct="1">
+              <a:lnSpc>
+                <a:spcPct val="100000"/>
+              </a:lnSpc>
+              <a:spcBef>
+                <a:spcPts val="0"/>
+              </a:spcBef>
+              <a:spcAft>
+                <a:spcPts val="0"/>
+              </a:spcAft>
+              <a:buClrTx/>
+              <a:buSzTx/>
+              <a:buFontTx/>
+              <a:buNone/>
+              <a:tabLst/>
+              <a:defRPr/>
+            </a:pPr>
+            <a:r>
+              <a:rPr lang="de-DE" sz="1200" b="0" kern="1200" dirty="0">
+                <a:solidFill>
+                  <a:schemeClr val="tx1"/>
+                </a:solidFill>
+                <a:effectLst/>
+                <a:latin typeface="+mn-lt"/>
+                <a:ea typeface="+mn-ea"/>
+                <a:cs typeface="+mn-cs"/>
+              </a:rPr>
               <a:t>Die Code-Vorstellung läuft am besten über `main.py`, weil dort alle Schritte sichtbar zusammenlaufen: Signale laden, Split anwenden, Features extrahieren, über `</a:t>
             </a:r>
             <a:r>
@@ -1218,7 +1275,21 @@
                 <a:ea typeface="+mn-ea"/>
                 <a:cs typeface="+mn-cs"/>
               </a:rPr>
-              <a:t> Die Training-Loss-Kurve zeigt, wie sich der Fehler während des Trainings entwickelt. Der Loss basiert auf den vorhergesagten Wahrscheinlichkeiten des MLP und den echten Labels. Wenn das Modell der richtigen Klasse eine hohe Wahrscheinlichkeit gibt, ist der Loss klein. Wenn es unsicher oder falsch liegt, steigt der Loss. In unseren Kurven sinkt der Loss deutlich ab, was zeigt, dass das Training funktioniert und das Modell die Trainingsdaten zunehmend besser beschreibt. Wichtig ist aber, dass ein niedriger Trainings-Loss allein nicht   ausreicht. Ein Modell kann auf Trainingsdaten sehr gut sein und trotzdem schlecht generalisieren. Deshalb bewerten wir zusätzlich mit Entwicklungssatz, Testsatz, ROC/AUC und Learning </a:t>
+              <a:t>David</a:t>
+            </a:r>
+          </a:p>
+          <a:p>
+            <a:r>
+              <a:rPr lang="de-DE" sz="1200" b="0" kern="1200" dirty="0">
+                <a:solidFill>
+                  <a:schemeClr val="tx1"/>
+                </a:solidFill>
+                <a:effectLst/>
+                <a:latin typeface="+mn-lt"/>
+                <a:ea typeface="+mn-ea"/>
+                <a:cs typeface="+mn-cs"/>
+              </a:rPr>
+              <a:t>Die Training-Loss-Kurve zeigt, wie sich der Fehler während des Trainings entwickelt. Der Loss basiert auf den vorhergesagten Wahrscheinlichkeiten des MLP und den echten Labels. Wenn das Modell der richtigen Klasse eine hohe Wahrscheinlichkeit gibt, ist der Loss klein. Wenn es unsicher oder falsch liegt, steigt der Loss. In unseren Kurven sinkt der Loss deutlich ab, was zeigt, dass das Training funktioniert und das Modell die Trainingsdaten zunehmend besser beschreibt. Wichtig ist aber, dass ein niedriger Trainings-Loss allein nicht   ausreicht. Ein Modell kann auf Trainingsdaten sehr gut sein und trotzdem schlecht generalisieren. Deshalb bewerten wir zusätzlich mit Entwicklungssatz, Testsatz, ROC/AUC und Learning </a:t>
             </a:r>
             <a:r>
               <a:rPr lang="de-DE" sz="1200" b="0" kern="1200" dirty="0" err="1">
@@ -1362,6 +1433,20 @@
                 <a:ea typeface="+mn-ea"/>
                 <a:cs typeface="+mn-cs"/>
               </a:rPr>
+              <a:t>Benjamin</a:t>
+            </a:r>
+          </a:p>
+          <a:p>
+            <a:r>
+              <a:rPr lang="de-DE" sz="1200" b="0" kern="1200" dirty="0">
+                <a:solidFill>
+                  <a:schemeClr val="tx1"/>
+                </a:solidFill>
+                <a:effectLst/>
+                <a:latin typeface="+mn-lt"/>
+                <a:ea typeface="+mn-ea"/>
+                <a:cs typeface="+mn-cs"/>
+              </a:rPr>
               <a:t>Die Learning </a:t>
             </a:r>
             <a:r>
@@ -1485,9 +1570,18 @@
           <a:lstStyle/>
           <a:p>
             <a:r>
-              <a:rPr lang="de-DE" dirty="0"/>
-              <a:t>B</a:t>
-            </a:r>
+              <a:rPr lang="de-DE" sz="1200" b="0" kern="1200" dirty="0">
+                <a:solidFill>
+                  <a:schemeClr val="tx1"/>
+                </a:solidFill>
+                <a:effectLst/>
+                <a:latin typeface="+mn-lt"/>
+                <a:ea typeface="+mn-ea"/>
+                <a:cs typeface="+mn-cs"/>
+              </a:rPr>
+              <a:t>Benjamin</a:t>
+            </a:r>
+            <a:endParaRPr lang="de-DE" dirty="0"/>
           </a:p>
         </p:txBody>
       </p:sp>
@@ -1597,9 +1691,18 @@
           <a:lstStyle/>
           <a:p>
             <a:r>
-              <a:rPr lang="de-DE" dirty="0"/>
-              <a:t>B</a:t>
-            </a:r>
+              <a:rPr lang="de-DE" sz="1200" b="0" kern="1200" dirty="0">
+                <a:solidFill>
+                  <a:schemeClr val="tx1"/>
+                </a:solidFill>
+                <a:effectLst/>
+                <a:latin typeface="+mn-lt"/>
+                <a:ea typeface="+mn-ea"/>
+                <a:cs typeface="+mn-cs"/>
+              </a:rPr>
+              <a:t>Benjamin</a:t>
+            </a:r>
+            <a:endParaRPr lang="de-DE" dirty="0"/>
           </a:p>
         </p:txBody>
       </p:sp>
@@ -1724,6 +1827,20 @@
                 <a:ea typeface="+mn-ea"/>
                 <a:cs typeface="+mn-cs"/>
               </a:rPr>
+              <a:t>Benjamin</a:t>
+            </a:r>
+          </a:p>
+          <a:p>
+            <a:r>
+              <a:rPr lang="de-DE" sz="1200" b="0" kern="1200" dirty="0">
+                <a:solidFill>
+                  <a:schemeClr val="tx1"/>
+                </a:solidFill>
+                <a:effectLst/>
+                <a:latin typeface="+mn-lt"/>
+                <a:ea typeface="+mn-ea"/>
+                <a:cs typeface="+mn-cs"/>
+              </a:rPr>
               <a:t>Die </a:t>
             </a:r>
             <a:r>
@@ -1880,6 +1997,20 @@
                 <a:ea typeface="+mn-ea"/>
                 <a:cs typeface="+mn-cs"/>
               </a:rPr>
+              <a:t>Benjamin</a:t>
+            </a:r>
+          </a:p>
+          <a:p>
+            <a:r>
+              <a:rPr lang="de-DE" sz="1200" b="0" kern="1200" dirty="0">
+                <a:solidFill>
+                  <a:schemeClr val="tx1"/>
+                </a:solidFill>
+                <a:effectLst/>
+                <a:latin typeface="+mn-lt"/>
+                <a:ea typeface="+mn-ea"/>
+                <a:cs typeface="+mn-cs"/>
+              </a:rPr>
               <a:t>Die ROC-Kurve zeigt, wie gut das Modell zwischen </a:t>
             </a:r>
             <a:r>
@@ -2047,6 +2178,37 @@
                 <a:ea typeface="+mn-ea"/>
                 <a:cs typeface="+mn-cs"/>
               </a:rPr>
+              <a:t>Tim</a:t>
+            </a:r>
+          </a:p>
+          <a:p>
+            <a:pPr marL="0" marR="0" lvl="0" indent="0" algn="l" defTabSz="914400" rtl="0" eaLnBrk="1" fontAlgn="auto" latinLnBrk="0" hangingPunct="1">
+              <a:lnSpc>
+                <a:spcPct val="100000"/>
+              </a:lnSpc>
+              <a:spcBef>
+                <a:spcPts val="0"/>
+              </a:spcBef>
+              <a:spcAft>
+                <a:spcPts val="0"/>
+              </a:spcAft>
+              <a:buClrTx/>
+              <a:buSzTx/>
+              <a:buFontTx/>
+              <a:buNone/>
+              <a:tabLst/>
+              <a:defRPr/>
+            </a:pPr>
+            <a:r>
+              <a:rPr lang="de-DE" sz="1200" b="0" kern="1200" dirty="0">
+                <a:solidFill>
+                  <a:schemeClr val="tx1"/>
+                </a:solidFill>
+                <a:effectLst/>
+                <a:latin typeface="+mn-lt"/>
+                <a:ea typeface="+mn-ea"/>
+                <a:cs typeface="+mn-cs"/>
+              </a:rPr>
               <a:t>Der wichtigste Diskussionsteil ist die Einordnung. Der neue Split prüft die guten Zahnräder strenger, weil `Z03` im Test nicht im Training vorkommt. Für die beschädigte Klasse bleibt die Aussage begrenzt, weil alle beschädigten Signale aus `Z05` stammen. Für eine robuste Aussage bräuchte man weitere beschädigte Zahnräder.</a:t>
             </a:r>
           </a:p>
@@ -2169,6 +2331,37 @@
                 <a:ea typeface="+mn-ea"/>
                 <a:cs typeface="+mn-cs"/>
               </a:rPr>
+              <a:t>Tim</a:t>
+            </a:r>
+          </a:p>
+          <a:p>
+            <a:pPr marL="0" marR="0" lvl="0" indent="0" algn="l" defTabSz="914400" rtl="0" eaLnBrk="1" fontAlgn="auto" latinLnBrk="0" hangingPunct="1">
+              <a:lnSpc>
+                <a:spcPct val="100000"/>
+              </a:lnSpc>
+              <a:spcBef>
+                <a:spcPts val="0"/>
+              </a:spcBef>
+              <a:spcAft>
+                <a:spcPts val="0"/>
+              </a:spcAft>
+              <a:buClrTx/>
+              <a:buSzTx/>
+              <a:buFontTx/>
+              <a:buNone/>
+              <a:tabLst/>
+              <a:defRPr/>
+            </a:pPr>
+            <a:r>
+              <a:rPr lang="de-DE" sz="1200" b="0" kern="1200" dirty="0">
+                <a:solidFill>
+                  <a:schemeClr val="tx1"/>
+                </a:solidFill>
+                <a:effectLst/>
+                <a:latin typeface="+mn-lt"/>
+                <a:ea typeface="+mn-ea"/>
+                <a:cs typeface="+mn-cs"/>
+              </a:rPr>
               <a:t>Zusammenfassend haben wir eine vollständige Klassifikationspipeline aufgebaut. Die wichtigsten methodischen Entscheidungen waren die Feature-Mittelung über `</a:t>
             </a:r>
             <a:r>
@@ -2288,15 +2481,18 @@
           <a:bodyPr/>
           <a:lstStyle/>
           <a:p>
-            <a:endParaRPr lang="de-DE" sz="1200" b="0" kern="1200" dirty="0">
-              <a:solidFill>
-                <a:schemeClr val="tx1"/>
-              </a:solidFill>
-              <a:effectLst/>
-              <a:latin typeface="+mn-lt"/>
-              <a:ea typeface="+mn-ea"/>
-              <a:cs typeface="+mn-cs"/>
-            </a:endParaRPr>
+            <a:r>
+              <a:rPr lang="de-DE" sz="1200" b="0" kern="1200" dirty="0">
+                <a:solidFill>
+                  <a:schemeClr val="tx1"/>
+                </a:solidFill>
+                <a:effectLst/>
+                <a:latin typeface="+mn-lt"/>
+                <a:ea typeface="+mn-ea"/>
+                <a:cs typeface="+mn-cs"/>
+              </a:rPr>
+              <a:t>Victor</a:t>
+            </a:r>
           </a:p>
         </p:txBody>
       </p:sp>
@@ -2404,6 +2600,10 @@
               <a:tabLst/>
               <a:defRPr/>
             </a:pPr>
+            <a:r>
+              <a:rPr lang="de-DE"/>
+              <a:t>Tim</a:t>
+            </a:r>
             <a:endParaRPr lang="de-DE" dirty="0"/>
           </a:p>
           <a:p>
@@ -2525,6 +2725,37 @@
                 <a:ea typeface="+mn-ea"/>
                 <a:cs typeface="+mn-cs"/>
               </a:rPr>
+              <a:t>Victor</a:t>
+            </a:r>
+          </a:p>
+          <a:p>
+            <a:pPr marL="0" marR="0" lvl="0" indent="0" algn="l" defTabSz="914400" rtl="0" eaLnBrk="1" fontAlgn="auto" latinLnBrk="0" hangingPunct="1">
+              <a:lnSpc>
+                <a:spcPct val="100000"/>
+              </a:lnSpc>
+              <a:spcBef>
+                <a:spcPts val="0"/>
+              </a:spcBef>
+              <a:spcAft>
+                <a:spcPts val="0"/>
+              </a:spcAft>
+              <a:buClrTx/>
+              <a:buSzTx/>
+              <a:buFontTx/>
+              <a:buNone/>
+              <a:tabLst/>
+              <a:defRPr/>
+            </a:pPr>
+            <a:r>
+              <a:rPr lang="de-DE" sz="1200" b="0" kern="1200" dirty="0">
+                <a:solidFill>
+                  <a:schemeClr val="tx1"/>
+                </a:solidFill>
+                <a:effectLst/>
+                <a:latin typeface="+mn-lt"/>
+                <a:ea typeface="+mn-ea"/>
+                <a:cs typeface="+mn-cs"/>
+              </a:rPr>
               <a:t>In Aufgabe 3 geht es darum, die Daten aus Aufgabe 2 nicht nur visuell zu untersuchen, sondern automatisch zu klassifizieren. Das Ziel ist eine binäre Entscheidung: Ist ein Signal einem guten oder einem beschädigten Zahnrad zuzuordnen? Dafür verwenden wir ein MLP und bewerten das Modell erst am Ende auf einem separaten Testsatz.</a:t>
             </a:r>
           </a:p>
@@ -2647,6 +2878,37 @@
                 <a:ea typeface="+mn-ea"/>
                 <a:cs typeface="+mn-cs"/>
               </a:rPr>
+              <a:t>Victor</a:t>
+            </a:r>
+          </a:p>
+          <a:p>
+            <a:pPr marL="0" marR="0" lvl="0" indent="0" algn="l" defTabSz="914400" rtl="0" eaLnBrk="1" fontAlgn="auto" latinLnBrk="0" hangingPunct="1">
+              <a:lnSpc>
+                <a:spcPct val="100000"/>
+              </a:lnSpc>
+              <a:spcBef>
+                <a:spcPts val="0"/>
+              </a:spcBef>
+              <a:spcAft>
+                <a:spcPts val="0"/>
+              </a:spcAft>
+              <a:buClrTx/>
+              <a:buSzTx/>
+              <a:buFontTx/>
+              <a:buNone/>
+              <a:tabLst/>
+              <a:defRPr/>
+            </a:pPr>
+            <a:r>
+              <a:rPr lang="de-DE" sz="1200" b="0" kern="1200" dirty="0">
+                <a:solidFill>
+                  <a:schemeClr val="tx1"/>
+                </a:solidFill>
+                <a:effectLst/>
+                <a:latin typeface="+mn-lt"/>
+                <a:ea typeface="+mn-ea"/>
+                <a:cs typeface="+mn-cs"/>
+              </a:rPr>
               <a:t>Die Label-Zuordnung basiert auf den Ergebnissen aus Aufgabe 2. Dort wurde `Z05` als beschädigt betrachtet, während `Z01` bis `Z04` als gut verwendet werden. Wichtig ist, dass nur eine Probe die Klasse 0 bildet. Das ist für die spätere Diskussion relevant, weil das Modell dadurch nicht viele verschiedene beschädigte Zahnräder sieht.</a:t>
             </a:r>
           </a:p>
@@ -2796,6 +3058,20 @@
         <p:txBody>
           <a:bodyPr/>
           <a:lstStyle/>
+          <a:p>
+            <a:r>
+              <a:rPr lang="de-DE" sz="1200" b="0" kern="1200" dirty="0">
+                <a:solidFill>
+                  <a:schemeClr val="tx1"/>
+                </a:solidFill>
+                <a:effectLst/>
+                <a:latin typeface="+mn-lt"/>
+                <a:ea typeface="+mn-ea"/>
+                <a:cs typeface="+mn-cs"/>
+              </a:rPr>
+              <a:t>Victor</a:t>
+            </a:r>
+          </a:p>
           <a:p>
             <a:r>
               <a:rPr lang="de-DE" sz="1200" b="0" kern="1200" dirty="0">
@@ -2951,6 +3227,29 @@
                 <a:ea typeface="+mn-ea"/>
                 <a:cs typeface="+mn-cs"/>
               </a:rPr>
+              <a:t>Victor</a:t>
+            </a:r>
+            <a:br>
+              <a:rPr lang="de-DE" sz="1200" b="0" kern="1200" dirty="0">
+                <a:solidFill>
+                  <a:schemeClr val="tx1"/>
+                </a:solidFill>
+                <a:effectLst/>
+                <a:latin typeface="+mn-lt"/>
+                <a:ea typeface="+mn-ea"/>
+                <a:cs typeface="+mn-cs"/>
+              </a:rPr>
+            </a:br>
+            <a:r>
+              <a:rPr lang="de-DE" sz="1200" b="0" kern="1200" dirty="0">
+                <a:solidFill>
+                  <a:schemeClr val="tx1"/>
+                </a:solidFill>
+                <a:effectLst/>
+                <a:latin typeface="+mn-lt"/>
+                <a:ea typeface="+mn-ea"/>
+                <a:cs typeface="+mn-cs"/>
+              </a:rPr>
               <a:t>Wir verwenden bewusst die Merkmale aus Aufgabe 2 weiter, weil diese bereits zu guten visuellen Trennungen geführt haben. Die Merkmale beschreiben sowohl zeitliche Eigenschaften als auch spektrale Eigenschaften des Signals. Dadurch muss das MLP nicht direkt auf den Rohsignalen lernen, sondern bekommt kompakte Signalbeschreibungen.</a:t>
             </a:r>
           </a:p>
@@ -3079,6 +3378,37 @@
                 <a:ea typeface="+mn-ea"/>
                 <a:cs typeface="+mn-cs"/>
               </a:rPr>
+              <a:t>Tim</a:t>
+            </a:r>
+          </a:p>
+          <a:p>
+            <a:pPr marL="0" marR="0" lvl="0" indent="0" algn="l" defTabSz="914400" rtl="0" eaLnBrk="1" fontAlgn="auto" latinLnBrk="0" hangingPunct="1">
+              <a:lnSpc>
+                <a:spcPct val="100000"/>
+              </a:lnSpc>
+              <a:spcBef>
+                <a:spcPts val="0"/>
+              </a:spcBef>
+              <a:spcAft>
+                <a:spcPts val="0"/>
+              </a:spcAft>
+              <a:buClrTx/>
+              <a:buSzTx/>
+              <a:buFontTx/>
+              <a:buNone/>
+              <a:tabLst/>
+              <a:defRPr/>
+            </a:pPr>
+            <a:r>
+              <a:rPr lang="de-DE" sz="1200" b="0" kern="1200" dirty="0">
+                <a:solidFill>
+                  <a:schemeClr val="tx1"/>
+                </a:solidFill>
+                <a:effectLst/>
+                <a:latin typeface="+mn-lt"/>
+                <a:ea typeface="+mn-ea"/>
+                <a:cs typeface="+mn-cs"/>
+              </a:rPr>
               <a:t>Wir extrahieren die Merkmale pro Roh-datei und mitteln danach die Feature-werte über alle `</a:t>
             </a:r>
             <a:r>
@@ -3197,6 +3527,37 @@
         <p:txBody>
           <a:bodyPr/>
           <a:lstStyle/>
+          <a:p>
+            <a:pPr marL="0" marR="0" lvl="0" indent="0" algn="l" defTabSz="914400" rtl="0" eaLnBrk="1" fontAlgn="auto" latinLnBrk="0" hangingPunct="1">
+              <a:lnSpc>
+                <a:spcPct val="100000"/>
+              </a:lnSpc>
+              <a:spcBef>
+                <a:spcPts val="0"/>
+              </a:spcBef>
+              <a:spcAft>
+                <a:spcPts val="0"/>
+              </a:spcAft>
+              <a:buClrTx/>
+              <a:buSzTx/>
+              <a:buFontTx/>
+              <a:buNone/>
+              <a:tabLst/>
+              <a:defRPr/>
+            </a:pPr>
+            <a:r>
+              <a:rPr lang="de-DE" sz="1200" b="0" kern="1200" dirty="0">
+                <a:solidFill>
+                  <a:schemeClr val="tx1"/>
+                </a:solidFill>
+                <a:effectLst/>
+                <a:latin typeface="+mn-lt"/>
+                <a:ea typeface="+mn-ea"/>
+                <a:cs typeface="+mn-cs"/>
+              </a:rPr>
+              <a:t>Tim</a:t>
+            </a:r>
+          </a:p>
           <a:p>
             <a:r>
               <a:rPr lang="de-DE" sz="1200" b="0" kern="1200" dirty="0">
@@ -3317,6 +3678,37 @@
         <p:txBody>
           <a:bodyPr/>
           <a:lstStyle/>
+          <a:p>
+            <a:pPr marL="0" marR="0" lvl="0" indent="0" algn="l" defTabSz="914400" rtl="0" eaLnBrk="1" fontAlgn="auto" latinLnBrk="0" hangingPunct="1">
+              <a:lnSpc>
+                <a:spcPct val="100000"/>
+              </a:lnSpc>
+              <a:spcBef>
+                <a:spcPts val="0"/>
+              </a:spcBef>
+              <a:spcAft>
+                <a:spcPts val="0"/>
+              </a:spcAft>
+              <a:buClrTx/>
+              <a:buSzTx/>
+              <a:buFontTx/>
+              <a:buNone/>
+              <a:tabLst/>
+              <a:defRPr/>
+            </a:pPr>
+            <a:r>
+              <a:rPr lang="de-DE" sz="1200" b="0" kern="1200" dirty="0">
+                <a:solidFill>
+                  <a:schemeClr val="tx1"/>
+                </a:solidFill>
+                <a:effectLst/>
+                <a:latin typeface="+mn-lt"/>
+                <a:ea typeface="+mn-ea"/>
+                <a:cs typeface="+mn-cs"/>
+              </a:rPr>
+              <a:t>David</a:t>
+            </a:r>
+          </a:p>
           <a:p>
             <a:r>
               <a:rPr lang="de-DE" sz="1200" b="0" kern="1200" dirty="0">
@@ -10883,18 +11275,7 @@
               <a:buFont typeface="Arial" panose="020B0604020202020204" pitchFamily="34" charset="0"/>
               <a:buChar char="•"/>
             </a:pPr>
-            <a:r>
-              <a:rPr lang="de-DE" dirty="0"/>
-              <a:t>Feature-Mittelung über `</a:t>
-            </a:r>
-            <a:r>
-              <a:rPr lang="de-DE" dirty="0" err="1"/>
-              <a:t>mID</a:t>
-            </a:r>
-            <a:r>
-              <a:rPr lang="de-DE" dirty="0"/>
-              <a:t>`</a:t>
-            </a:r>
+            <a:endParaRPr lang="de-DE" dirty="0"/>
           </a:p>
           <a:p>
             <a:pPr>
@@ -10903,7 +11284,15 @@
             </a:pPr>
             <a:r>
               <a:rPr lang="de-DE" dirty="0"/>
-              <a:t>Merkmalsextraktion pro Datei vor der Mittelung</a:t>
+              <a:t>Feature-Mittelung über `</a:t>
+            </a:r>
+            <a:r>
+              <a:rPr lang="de-DE" dirty="0" err="1"/>
+              <a:t>mID</a:t>
+            </a:r>
+            <a:r>
+              <a:rPr lang="de-DE" dirty="0"/>
+              <a:t>`</a:t>
             </a:r>
           </a:p>
           <a:p>
@@ -10913,47 +11302,7 @@
             </a:pPr>
             <a:r>
               <a:rPr lang="de-DE" dirty="0"/>
-              <a:t>Fester Split über Zahnräder:</a:t>
-            </a:r>
-          </a:p>
-          <a:p>
-            <a:pPr lvl="1">
-              <a:buFont typeface="Arial" panose="020B0604020202020204" pitchFamily="34" charset="0"/>
-              <a:buChar char="•"/>
-            </a:pPr>
-            <a:r>
-              <a:rPr lang="de-DE" dirty="0"/>
-              <a:t>Train: Z01, Z02</a:t>
-            </a:r>
-          </a:p>
-          <a:p>
-            <a:pPr lvl="1">
-              <a:buFont typeface="Arial" panose="020B0604020202020204" pitchFamily="34" charset="0"/>
-              <a:buChar char="•"/>
-            </a:pPr>
-            <a:r>
-              <a:rPr lang="de-DE" dirty="0"/>
-              <a:t>Dev: Z04</a:t>
-            </a:r>
-          </a:p>
-          <a:p>
-            <a:pPr lvl="1">
-              <a:buFont typeface="Arial" panose="020B0604020202020204" pitchFamily="34" charset="0"/>
-              <a:buChar char="•"/>
-            </a:pPr>
-            <a:r>
-              <a:rPr lang="de-DE" dirty="0"/>
-              <a:t>Test: Z03</a:t>
-            </a:r>
-          </a:p>
-          <a:p>
-            <a:pPr>
-              <a:buFont typeface="Arial" panose="020B0604020202020204" pitchFamily="34" charset="0"/>
-              <a:buChar char="•"/>
-            </a:pPr>
-            <a:r>
-              <a:rPr lang="de-DE" dirty="0"/>
-              <a:t>Z05 positionsbasiert auf alle Splits verteilt</a:t>
+              <a:t>Merkmalsextraktion pro Datei vor der Mittelung</a:t>
             </a:r>
           </a:p>
           <a:p>

</xml_diff>